<commit_message>
Rebuild the deck, HLD and workflow diagram with the finale evidence
The HLD now includes the requirements traceability; the deck shows the
measured ANPR accuracy and drops a rectification stage that was never built.

Co-authored-by: Copilot <223556219+Copilot@users.noreply.github.com>
</commit_message>
<xml_diff>
--- a/docs/Sentinel-Platform-Deck.pptx
+++ b/docs/Sentinel-Platform-Deck.pptx
@@ -5694,7 +5694,7 @@
                 <a:ea typeface="Arial" pitchFamily="34" charset="-122"/>
                 <a:cs typeface="Arial" pitchFamily="34" charset="-120"/>
               </a:rPr>
-              <a:t>Zones, tamper, vehicle colour</a:t>
+              <a:t>Zones, tamper, colour, people count</a:t>
             </a:r>
             <a:endParaRPr lang="en-US" sz="1100" dirty="0"/>
           </a:p>
@@ -5837,7 +5837,7 @@
                 <a:ea typeface="Arial" pitchFamily="34" charset="-122"/>
                 <a:cs typeface="Arial" pitchFamily="34" charset="-120"/>
               </a:rPr>
-              <a:t>An ANPR accuracy number</a:t>
+              <a:t>ANPR accuracy beyond one camera</a:t>
             </a:r>
             <a:endParaRPr lang="en-US" sz="1100" dirty="0"/>
           </a:p>
@@ -9754,7 +9754,7 @@
                 <a:ea typeface="Arial" pitchFamily="34" charset="-122"/>
                 <a:cs typeface="Arial" pitchFamily="34" charset="-120"/>
               </a:rPr>
-              <a:t>VAHAN / SARTHI / eGujCop / AFIS registry clients</a:t>
+              <a:t>VAHAN / SARTHI / eGujCop / AFIS / NAFIS clients</a:t>
             </a:r>
             <a:endParaRPr lang="en-US" sz="1250" dirty="0"/>
           </a:p>
@@ -10159,7 +10159,7 @@
                 <a:ea typeface="Arial" pitchFamily="34" charset="-122"/>
                 <a:cs typeface="Arial" pitchFamily="34" charset="-120"/>
               </a:rPr>
-              <a:t>Rectify</a:t>
+              <a:t>OCR</a:t>
             </a:r>
             <a:endParaRPr lang="en-US" sz="900" dirty="0"/>
           </a:p>
@@ -10218,7 +10218,7 @@
                 <a:ea typeface="Arial" pitchFamily="34" charset="-122"/>
                 <a:cs typeface="Arial" pitchFamily="34" charset="-120"/>
               </a:rPr>
-              <a:t>OCR</a:t>
+              <a:t>Grammar fix</a:t>
             </a:r>
             <a:endParaRPr lang="en-US" sz="900" dirty="0"/>
           </a:p>
@@ -10592,7 +10592,7 @@
                 <a:ea typeface="Trebuchet MS" pitchFamily="34" charset="-122"/>
                 <a:cs typeface="Trebuchet MS" pitchFamily="34" charset="-120"/>
               </a:rPr>
-              <a:t>No accuracy %</a:t>
+              <a:t>65% / 78%</a:t>
             </a:r>
             <a:endParaRPr lang="en-US" sz="2100" dirty="0"/>
           </a:p>
@@ -10631,7 +10631,7 @@
                 <a:ea typeface="Arial" pitchFamily="34" charset="-122"/>
                 <a:cs typeface="Arial" pitchFamily="34" charset="-120"/>
               </a:rPr>
-              <a:t>claimed — needs a hand-labelled holdout we do not have</a:t>
+              <a:t>exact per crop / voted, 81 labelled plates; target 85%</a:t>
             </a:r>
             <a:endParaRPr lang="en-US" sz="1050" dirty="0"/>
           </a:p>
@@ -10670,7 +10670,7 @@
                 <a:ea typeface="Arial" pitchFamily="34" charset="-122"/>
                 <a:cs typeface="Arial" pitchFamily="34" charset="-120"/>
               </a:rPr>
-              <a:t>The third box is the one worth reading.</a:t>
+              <a:t>The third box is measured, not estimated, and it is not yet good enough.</a:t>
             </a:r>
             <a:endParaRPr lang="en-US" sz="1200" dirty="0"/>
           </a:p>

</xml_diff>